<commit_message>
Updated investor metrics to consider total assets and profit after tax growth across the 3 companies
</commit_message>
<xml_diff>
--- a/outputs/generated_reports/gtco_pbt_analysis.pptx
+++ b/outputs/generated_reports/gtco_pbt_analysis.pptx
@@ -10,7 +10,6 @@
     <p:sldId id="258" r:id="rId9"/>
     <p:sldId id="259" r:id="rId10"/>
     <p:sldId id="260" r:id="rId11"/>
-    <p:sldId id="261" r:id="rId12"/>
   </p:sldIdLst>
   <p:sldSz cx="12191695" cy="6858000" type="screen4x3"/>
   <p:notesSz cx="6858000" cy="9144000"/>
@@ -161,10 +160,10 @@
                 <c:formatCode>General</c:formatCode>
                 <c:ptCount val="2"/>
                 <c:pt idx="0">
-                  <c:v>609.3</c:v>
+                  <c:v>609.31</c:v>
                 </c:pt>
                 <c:pt idx="1">
-                  <c:v>1266.2</c:v>
+                  <c:v>1266.25</c:v>
                 </c:pt>
               </c:numCache>
             </c:numRef>
@@ -3371,7 +3370,7 @@
               </a:defRPr>
             </a:pPr>
             <a:r>
-              <a:t>Comparison of 2023 and 2024 Performance</a:t>
+              <a:t>2023 vs. 2024 Performance</a:t>
             </a:r>
           </a:p>
         </p:txBody>
@@ -3467,7 +3466,7 @@
               </a:defRPr>
             </a:pPr>
             <a:r>
-              <a:t>Key Financial Metrics</a:t>
+              <a:t>Profit Before Tax (Group)</a:t>
             </a:r>
           </a:p>
         </p:txBody>
@@ -3480,8 +3479,8 @@
         </p:nvSpPr>
         <p:spPr>
           <a:xfrm>
-            <a:off x="1005840" y="2020824"/>
-            <a:ext cx="4846320" cy="2148840"/>
+            <a:off x="914400" y="1837943"/>
+            <a:ext cx="4892040" cy="2148840"/>
           </a:xfrm>
           <a:prstGeom prst="roundRect">
             <a:avLst/>
@@ -3523,8 +3522,8 @@
         </p:nvSpPr>
         <p:spPr>
           <a:xfrm>
-            <a:off x="960120" y="1965960"/>
-            <a:ext cx="4846320" cy="2148840"/>
+            <a:off x="868680" y="1783080"/>
+            <a:ext cx="4892040" cy="2148840"/>
           </a:xfrm>
           <a:prstGeom prst="roundRect">
             <a:avLst/>
@@ -3568,7 +3567,7 @@
         </p:nvSpPr>
         <p:spPr>
           <a:xfrm>
-            <a:off x="960120" y="1965960"/>
+            <a:off x="868680" y="1783080"/>
             <a:ext cx="73152" cy="2148840"/>
           </a:xfrm>
           <a:prstGeom prst="rect">
@@ -3611,8 +3610,8 @@
         </p:nvSpPr>
         <p:spPr>
           <a:xfrm>
-            <a:off x="1234440" y="2221991"/>
-            <a:ext cx="4343400" cy="320040"/>
+            <a:off x="1143000" y="2039112"/>
+            <a:ext cx="4389120" cy="320040"/>
           </a:xfrm>
           <a:prstGeom prst="rect">
             <a:avLst/>
@@ -3633,7 +3632,7 @@
               </a:defRPr>
             </a:pPr>
             <a:r>
-              <a:t>2023 PBT (GROUP)</a:t>
+              <a:t>2023 PBT</a:t>
             </a:r>
           </a:p>
         </p:txBody>
@@ -3646,8 +3645,8 @@
         </p:nvSpPr>
         <p:spPr>
           <a:xfrm>
-            <a:off x="1234440" y="2697480"/>
-            <a:ext cx="4343400" cy="640080"/>
+            <a:off x="1143000" y="2514600"/>
+            <a:ext cx="4389120" cy="640080"/>
           </a:xfrm>
           <a:prstGeom prst="rect">
             <a:avLst/>
@@ -3668,56 +3667,21 @@
               </a:defRPr>
             </a:pPr>
             <a:r>
-              <a:t>₦609.3bn</a:t>
-            </a:r>
-          </a:p>
-        </p:txBody>
-      </p:sp>
-      <p:sp>
-        <p:nvSpPr>
-          <p:cNvPr id="9" name="TextBox 8"/>
-          <p:cNvSpPr txBox="1"/>
-          <p:nvPr/>
-        </p:nvSpPr>
-        <p:spPr>
-          <a:xfrm>
-            <a:off x="1234440" y="3383280"/>
-            <a:ext cx="4343400" cy="365760"/>
-          </a:xfrm>
-          <a:prstGeom prst="rect">
-            <a:avLst/>
-          </a:prstGeom>
-          <a:noFill/>
-        </p:spPr>
-        <p:txBody>
-          <a:bodyPr wrap="none">
-            <a:spAutoFit/>
-          </a:bodyPr>
-          <a:lstStyle/>
-          <a:p>
-            <a:pPr>
-              <a:defRPr sz="1000">
-                <a:solidFill>
-                  <a:srgbClr val="64748B"/>
-                </a:solidFill>
-              </a:defRPr>
-            </a:pPr>
-            <a:r>
-              <a:t>In thousands of Nigerian Naira</a:t>
-            </a:r>
-          </a:p>
-        </p:txBody>
-      </p:sp>
-      <p:sp>
-        <p:nvSpPr>
-          <p:cNvPr id="10" name="Rounded Rectangle 9"/>
+              <a:t>₦609.31bn</a:t>
+            </a:r>
+          </a:p>
+        </p:txBody>
+      </p:sp>
+      <p:sp>
+        <p:nvSpPr>
+          <p:cNvPr id="9" name="Rounded Rectangle 8"/>
           <p:cNvSpPr/>
           <p:nvPr/>
         </p:nvSpPr>
         <p:spPr>
           <a:xfrm>
-            <a:off x="6172199" y="2020824"/>
-            <a:ext cx="4846320" cy="2148840"/>
+            <a:off x="6446520" y="1837943"/>
+            <a:ext cx="4892040" cy="2148840"/>
           </a:xfrm>
           <a:prstGeom prst="roundRect">
             <a:avLst/>
@@ -3753,14 +3717,14 @@
       </p:sp>
       <p:sp>
         <p:nvSpPr>
-          <p:cNvPr id="11" name="Rounded Rectangle 10"/>
+          <p:cNvPr id="10" name="Rounded Rectangle 9"/>
           <p:cNvSpPr/>
           <p:nvPr/>
         </p:nvSpPr>
         <p:spPr>
           <a:xfrm>
-            <a:off x="6126479" y="1965960"/>
-            <a:ext cx="4846320" cy="2148840"/>
+            <a:off x="6400800" y="1783080"/>
+            <a:ext cx="4892040" cy="2148840"/>
           </a:xfrm>
           <a:prstGeom prst="roundRect">
             <a:avLst/>
@@ -3798,13 +3762,13 @@
       </p:sp>
       <p:sp>
         <p:nvSpPr>
-          <p:cNvPr id="12" name="Rectangle 11"/>
+          <p:cNvPr id="11" name="Rectangle 10"/>
           <p:cNvSpPr/>
           <p:nvPr/>
         </p:nvSpPr>
         <p:spPr>
           <a:xfrm>
-            <a:off x="6126479" y="1965960"/>
+            <a:off x="6400800" y="1783080"/>
             <a:ext cx="73152" cy="2148840"/>
           </a:xfrm>
           <a:prstGeom prst="rect">
@@ -3841,14 +3805,14 @@
       </p:sp>
       <p:sp>
         <p:nvSpPr>
-          <p:cNvPr id="13" name="TextBox 12"/>
+          <p:cNvPr id="12" name="TextBox 11"/>
           <p:cNvSpPr txBox="1"/>
           <p:nvPr/>
         </p:nvSpPr>
         <p:spPr>
           <a:xfrm>
-            <a:off x="6400799" y="2221991"/>
-            <a:ext cx="4343400" cy="320040"/>
+            <a:off x="6675120" y="2039112"/>
+            <a:ext cx="4389120" cy="320040"/>
           </a:xfrm>
           <a:prstGeom prst="rect">
             <a:avLst/>
@@ -3869,21 +3833,21 @@
               </a:defRPr>
             </a:pPr>
             <a:r>
-              <a:t>2024 PBT (GROUP)</a:t>
-            </a:r>
-          </a:p>
-        </p:txBody>
-      </p:sp>
-      <p:sp>
-        <p:nvSpPr>
-          <p:cNvPr id="14" name="TextBox 13"/>
+              <a:t>2024 PBT</a:t>
+            </a:r>
+          </a:p>
+        </p:txBody>
+      </p:sp>
+      <p:sp>
+        <p:nvSpPr>
+          <p:cNvPr id="13" name="TextBox 12"/>
           <p:cNvSpPr txBox="1"/>
           <p:nvPr/>
         </p:nvSpPr>
         <p:spPr>
           <a:xfrm>
-            <a:off x="6400799" y="2697480"/>
-            <a:ext cx="4343400" cy="640080"/>
+            <a:off x="6675120" y="2514600"/>
+            <a:ext cx="4389120" cy="640080"/>
           </a:xfrm>
           <a:prstGeom prst="rect">
             <a:avLst/>
@@ -3904,62 +3868,27 @@
               </a:defRPr>
             </a:pPr>
             <a:r>
-              <a:t>₦1,266.2bn</a:t>
-            </a:r>
-          </a:p>
-        </p:txBody>
-      </p:sp>
-      <p:sp>
-        <p:nvSpPr>
-          <p:cNvPr id="15" name="TextBox 14"/>
-          <p:cNvSpPr txBox="1"/>
-          <p:nvPr/>
-        </p:nvSpPr>
-        <p:spPr>
-          <a:xfrm>
-            <a:off x="6400799" y="3383280"/>
-            <a:ext cx="4343400" cy="365760"/>
-          </a:xfrm>
-          <a:prstGeom prst="rect">
-            <a:avLst/>
-          </a:prstGeom>
-          <a:noFill/>
-        </p:spPr>
-        <p:txBody>
-          <a:bodyPr wrap="none">
-            <a:spAutoFit/>
-          </a:bodyPr>
-          <a:lstStyle/>
-          <a:p>
-            <a:pPr>
-              <a:defRPr sz="1000">
-                <a:solidFill>
-                  <a:srgbClr val="64748B"/>
-                </a:solidFill>
-              </a:defRPr>
-            </a:pPr>
-            <a:r>
-              <a:t>In thousands of Nigerian Naira</a:t>
-            </a:r>
-          </a:p>
-        </p:txBody>
-      </p:sp>
-      <p:sp>
-        <p:nvSpPr>
-          <p:cNvPr id="16" name="Rectangle 15"/>
+              <a:t>₦1.266tn</a:t>
+            </a:r>
+          </a:p>
+        </p:txBody>
+      </p:sp>
+      <p:sp>
+        <p:nvSpPr>
+          <p:cNvPr id="14" name="Right Arrow 13"/>
           <p:cNvSpPr/>
           <p:nvPr/>
         </p:nvSpPr>
         <p:spPr>
           <a:xfrm>
-            <a:off x="0" y="6510528"/>
-            <a:ext cx="12191695" cy="36576"/>
-          </a:xfrm>
-          <a:prstGeom prst="rect">
+            <a:off x="5669280" y="2468880"/>
+            <a:ext cx="566928" cy="384048"/>
+          </a:xfrm>
+          <a:prstGeom prst="rightArrow">
             <a:avLst/>
           </a:prstGeom>
           <a:solidFill>
-            <a:srgbClr val="E6B14D"/>
+            <a:srgbClr val="64748B"/>
           </a:solidFill>
           <a:ln>
             <a:noFill/>
@@ -3989,6 +3918,84 @@
       </p:sp>
       <p:sp>
         <p:nvSpPr>
+          <p:cNvPr id="15" name="TextBox 14"/>
+          <p:cNvSpPr txBox="1"/>
+          <p:nvPr/>
+        </p:nvSpPr>
+        <p:spPr>
+          <a:xfrm>
+            <a:off x="914400" y="4617720"/>
+            <a:ext cx="10332720" cy="868680"/>
+          </a:xfrm>
+          <a:prstGeom prst="rect">
+            <a:avLst/>
+          </a:prstGeom>
+          <a:noFill/>
+        </p:spPr>
+        <p:txBody>
+          <a:bodyPr wrap="none">
+            <a:spAutoFit/>
+          </a:bodyPr>
+          <a:lstStyle/>
+          <a:p>
+            <a:pPr algn="ctr">
+              <a:defRPr sz="2100" b="1">
+                <a:solidFill>
+                  <a:srgbClr val="0D2340"/>
+                </a:solidFill>
+              </a:defRPr>
+            </a:pPr>
+            <a:r>
+              <a:t>GTCO's Group Profit Before Tax more than doubled from 2023 to 2024.</a:t>
+            </a:r>
+          </a:p>
+        </p:txBody>
+      </p:sp>
+      <p:sp>
+        <p:nvSpPr>
+          <p:cNvPr id="16" name="Rectangle 15"/>
+          <p:cNvSpPr/>
+          <p:nvPr/>
+        </p:nvSpPr>
+        <p:spPr>
+          <a:xfrm>
+            <a:off x="0" y="6510528"/>
+            <a:ext cx="12191695" cy="36576"/>
+          </a:xfrm>
+          <a:prstGeom prst="rect">
+            <a:avLst/>
+          </a:prstGeom>
+          <a:solidFill>
+            <a:srgbClr val="E6B14D"/>
+          </a:solidFill>
+          <a:ln>
+            <a:noFill/>
+          </a:ln>
+        </p:spPr>
+        <p:style>
+          <a:lnRef idx="1">
+            <a:schemeClr val="accent1"/>
+          </a:lnRef>
+          <a:fillRef idx="3">
+            <a:schemeClr val="accent1"/>
+          </a:fillRef>
+          <a:effectRef idx="2">
+            <a:schemeClr val="accent1"/>
+          </a:effectRef>
+          <a:fontRef idx="minor">
+            <a:schemeClr val="lt1"/>
+          </a:fontRef>
+        </p:style>
+        <p:txBody>
+          <a:bodyPr rtlCol="0" anchor="ctr"/>
+          <a:lstStyle/>
+          <a:p>
+            <a:pPr algn="ctr"/>
+          </a:p>
+        </p:txBody>
+      </p:sp>
+      <p:sp>
+        <p:nvSpPr>
           <p:cNvPr id="17" name="TextBox 16"/>
           <p:cNvSpPr txBox="1"/>
           <p:nvPr/>
@@ -4017,7 +4024,7 @@
               </a:defRPr>
             </a:pPr>
             <a:r>
-              <a:t>Source: GTCO 2024 Annual Report, p. 129</a:t>
+              <a:t>Source: GTCO 2023 Annual Report, p. 8; GTCO 2024 Annual Report, p. 78</a:t>
             </a:r>
           </a:p>
         </p:txBody>
@@ -4113,7 +4120,7 @@
               </a:defRPr>
             </a:pPr>
             <a:r>
-              <a:t>Profit Growth</a:t>
+              <a:t>Profit Before Tax Growth</a:t>
             </a:r>
           </a:p>
         </p:txBody>
@@ -4183,7 +4190,7 @@
               </a:defRPr>
             </a:pPr>
             <a:r>
-              <a:t>Increase in Group Profit Before Tax from 2023 to 2024</a:t>
+              <a:t>Percentage increase in Group Profit Before Tax from 2023 to 2024</a:t>
             </a:r>
           </a:p>
         </p:txBody>
@@ -4261,7 +4268,7 @@
               </a:defRPr>
             </a:pPr>
             <a:r>
-              <a:t>Source: Calculated from annual-report values</a:t>
+              <a:t>Source: Calculated from GTCO annual report values</a:t>
             </a:r>
           </a:p>
         </p:txBody>
@@ -4299,7 +4306,7 @@
             <a:avLst/>
           </a:prstGeom>
           <a:solidFill>
-            <a:srgbClr val="F6F8FB"/>
+            <a:srgbClr val="FFFFFF"/>
           </a:solidFill>
           <a:ln>
             <a:noFill/>
@@ -4357,27 +4364,45 @@
               </a:defRPr>
             </a:pPr>
             <a:r>
-              <a:t>Profit Before Tax Comparison</a:t>
-            </a:r>
-          </a:p>
-        </p:txBody>
-      </p:sp>
-      <p:sp>
-        <p:nvSpPr>
-          <p:cNvPr id="4" name="Rounded Rectangle 3"/>
+              <a:t>GTCO Group Profit Before Tax Trend</a:t>
+            </a:r>
+          </a:p>
+        </p:txBody>
+      </p:sp>
+      <p:graphicFrame>
+        <p:nvGraphicFramePr>
+          <p:cNvPr id="4" name="Chart 3"/>
+          <p:cNvGraphicFramePr>
+            <a:graphicFrameLocks noGrp="1"/>
+          </p:cNvGraphicFramePr>
+          <p:nvPr/>
+        </p:nvGraphicFramePr>
+        <p:xfrm>
+          <a:off x="914400" y="1417320"/>
+          <a:ext cx="10424160" cy="4526280"/>
+        </p:xfrm>
+        <a:graphic>
+          <a:graphicData uri="http://schemas.openxmlformats.org/drawingml/2006/chart">
+            <c:chart xmlns:c="http://schemas.openxmlformats.org/drawingml/2006/chart" r:id="rId2"/>
+          </a:graphicData>
+        </a:graphic>
+      </p:graphicFrame>
+      <p:sp>
+        <p:nvSpPr>
+          <p:cNvPr id="5" name="Rectangle 4"/>
           <p:cNvSpPr/>
           <p:nvPr/>
         </p:nvSpPr>
         <p:spPr>
           <a:xfrm>
-            <a:off x="914400" y="1837943"/>
-            <a:ext cx="4892040" cy="2148840"/>
-          </a:xfrm>
-          <a:prstGeom prst="roundRect">
+            <a:off x="0" y="6510528"/>
+            <a:ext cx="12191695" cy="36576"/>
+          </a:xfrm>
+          <a:prstGeom prst="rect">
             <a:avLst/>
           </a:prstGeom>
           <a:solidFill>
-            <a:srgbClr val="E6E9EE"/>
+            <a:srgbClr val="E6B14D"/>
           </a:solidFill>
           <a:ln>
             <a:noFill/>
@@ -4407,487 +4432,7 @@
       </p:sp>
       <p:sp>
         <p:nvSpPr>
-          <p:cNvPr id="5" name="Rounded Rectangle 4"/>
-          <p:cNvSpPr/>
-          <p:nvPr/>
-        </p:nvSpPr>
-        <p:spPr>
-          <a:xfrm>
-            <a:off x="868680" y="1783080"/>
-            <a:ext cx="4892040" cy="2148840"/>
-          </a:xfrm>
-          <a:prstGeom prst="roundRect">
-            <a:avLst/>
-          </a:prstGeom>
-          <a:solidFill>
-            <a:srgbClr val="FFFFFF"/>
-          </a:solidFill>
-          <a:ln>
-            <a:solidFill>
-              <a:srgbClr val="E2E8F0"/>
-            </a:solidFill>
-          </a:ln>
-        </p:spPr>
-        <p:style>
-          <a:lnRef idx="1">
-            <a:schemeClr val="accent1"/>
-          </a:lnRef>
-          <a:fillRef idx="3">
-            <a:schemeClr val="accent1"/>
-          </a:fillRef>
-          <a:effectRef idx="2">
-            <a:schemeClr val="accent1"/>
-          </a:effectRef>
-          <a:fontRef idx="minor">
-            <a:schemeClr val="lt1"/>
-          </a:fontRef>
-        </p:style>
-        <p:txBody>
-          <a:bodyPr rtlCol="0" anchor="ctr"/>
-          <a:lstStyle/>
-          <a:p>
-            <a:pPr algn="ctr"/>
-          </a:p>
-        </p:txBody>
-      </p:sp>
-      <p:sp>
-        <p:nvSpPr>
-          <p:cNvPr id="6" name="Rectangle 5"/>
-          <p:cNvSpPr/>
-          <p:nvPr/>
-        </p:nvSpPr>
-        <p:spPr>
-          <a:xfrm>
-            <a:off x="868680" y="1783080"/>
-            <a:ext cx="73152" cy="2148840"/>
-          </a:xfrm>
-          <a:prstGeom prst="rect">
-            <a:avLst/>
-          </a:prstGeom>
-          <a:solidFill>
-            <a:srgbClr val="205B9B"/>
-          </a:solidFill>
-          <a:ln>
-            <a:noFill/>
-          </a:ln>
-        </p:spPr>
-        <p:style>
-          <a:lnRef idx="1">
-            <a:schemeClr val="accent1"/>
-          </a:lnRef>
-          <a:fillRef idx="3">
-            <a:schemeClr val="accent1"/>
-          </a:fillRef>
-          <a:effectRef idx="2">
-            <a:schemeClr val="accent1"/>
-          </a:effectRef>
-          <a:fontRef idx="minor">
-            <a:schemeClr val="lt1"/>
-          </a:fontRef>
-        </p:style>
-        <p:txBody>
-          <a:bodyPr rtlCol="0" anchor="ctr"/>
-          <a:lstStyle/>
-          <a:p>
-            <a:pPr algn="ctr"/>
-          </a:p>
-        </p:txBody>
-      </p:sp>
-      <p:sp>
-        <p:nvSpPr>
-          <p:cNvPr id="7" name="TextBox 6"/>
-          <p:cNvSpPr txBox="1"/>
-          <p:nvPr/>
-        </p:nvSpPr>
-        <p:spPr>
-          <a:xfrm>
-            <a:off x="1143000" y="2039112"/>
-            <a:ext cx="4389120" cy="320040"/>
-          </a:xfrm>
-          <a:prstGeom prst="rect">
-            <a:avLst/>
-          </a:prstGeom>
-          <a:noFill/>
-        </p:spPr>
-        <p:txBody>
-          <a:bodyPr wrap="none">
-            <a:spAutoFit/>
-          </a:bodyPr>
-          <a:lstStyle/>
-          <a:p>
-            <a:pPr>
-              <a:defRPr sz="1100" b="1">
-                <a:solidFill>
-                  <a:srgbClr val="64748B"/>
-                </a:solidFill>
-              </a:defRPr>
-            </a:pPr>
-            <a:r>
-              <a:t>2023 PBT</a:t>
-            </a:r>
-          </a:p>
-        </p:txBody>
-      </p:sp>
-      <p:sp>
-        <p:nvSpPr>
-          <p:cNvPr id="8" name="TextBox 7"/>
-          <p:cNvSpPr txBox="1"/>
-          <p:nvPr/>
-        </p:nvSpPr>
-        <p:spPr>
-          <a:xfrm>
-            <a:off x="1143000" y="2514600"/>
-            <a:ext cx="4389120" cy="640080"/>
-          </a:xfrm>
-          <a:prstGeom prst="rect">
-            <a:avLst/>
-          </a:prstGeom>
-          <a:noFill/>
-        </p:spPr>
-        <p:txBody>
-          <a:bodyPr wrap="none">
-            <a:spAutoFit/>
-          </a:bodyPr>
-          <a:lstStyle/>
-          <a:p>
-            <a:pPr>
-              <a:defRPr sz="2500" b="1">
-                <a:solidFill>
-                  <a:srgbClr val="205B9B"/>
-                </a:solidFill>
-              </a:defRPr>
-            </a:pPr>
-            <a:r>
-              <a:t>₦609.3bn</a:t>
-            </a:r>
-          </a:p>
-        </p:txBody>
-      </p:sp>
-      <p:sp>
-        <p:nvSpPr>
-          <p:cNvPr id="9" name="Rounded Rectangle 8"/>
-          <p:cNvSpPr/>
-          <p:nvPr/>
-        </p:nvSpPr>
-        <p:spPr>
-          <a:xfrm>
-            <a:off x="6446520" y="1837943"/>
-            <a:ext cx="4892040" cy="2148840"/>
-          </a:xfrm>
-          <a:prstGeom prst="roundRect">
-            <a:avLst/>
-          </a:prstGeom>
-          <a:solidFill>
-            <a:srgbClr val="E6E9EE"/>
-          </a:solidFill>
-          <a:ln>
-            <a:noFill/>
-          </a:ln>
-        </p:spPr>
-        <p:style>
-          <a:lnRef idx="1">
-            <a:schemeClr val="accent1"/>
-          </a:lnRef>
-          <a:fillRef idx="3">
-            <a:schemeClr val="accent1"/>
-          </a:fillRef>
-          <a:effectRef idx="2">
-            <a:schemeClr val="accent1"/>
-          </a:effectRef>
-          <a:fontRef idx="minor">
-            <a:schemeClr val="lt1"/>
-          </a:fontRef>
-        </p:style>
-        <p:txBody>
-          <a:bodyPr rtlCol="0" anchor="ctr"/>
-          <a:lstStyle/>
-          <a:p>
-            <a:pPr algn="ctr"/>
-          </a:p>
-        </p:txBody>
-      </p:sp>
-      <p:sp>
-        <p:nvSpPr>
-          <p:cNvPr id="10" name="Rounded Rectangle 9"/>
-          <p:cNvSpPr/>
-          <p:nvPr/>
-        </p:nvSpPr>
-        <p:spPr>
-          <a:xfrm>
-            <a:off x="6400800" y="1783080"/>
-            <a:ext cx="4892040" cy="2148840"/>
-          </a:xfrm>
-          <a:prstGeom prst="roundRect">
-            <a:avLst/>
-          </a:prstGeom>
-          <a:solidFill>
-            <a:srgbClr val="FFFFFF"/>
-          </a:solidFill>
-          <a:ln>
-            <a:solidFill>
-              <a:srgbClr val="E2E8F0"/>
-            </a:solidFill>
-          </a:ln>
-        </p:spPr>
-        <p:style>
-          <a:lnRef idx="1">
-            <a:schemeClr val="accent1"/>
-          </a:lnRef>
-          <a:fillRef idx="3">
-            <a:schemeClr val="accent1"/>
-          </a:fillRef>
-          <a:effectRef idx="2">
-            <a:schemeClr val="accent1"/>
-          </a:effectRef>
-          <a:fontRef idx="minor">
-            <a:schemeClr val="lt1"/>
-          </a:fontRef>
-        </p:style>
-        <p:txBody>
-          <a:bodyPr rtlCol="0" anchor="ctr"/>
-          <a:lstStyle/>
-          <a:p>
-            <a:pPr algn="ctr"/>
-          </a:p>
-        </p:txBody>
-      </p:sp>
-      <p:sp>
-        <p:nvSpPr>
-          <p:cNvPr id="11" name="Rectangle 10"/>
-          <p:cNvSpPr/>
-          <p:nvPr/>
-        </p:nvSpPr>
-        <p:spPr>
-          <a:xfrm>
-            <a:off x="6400800" y="1783080"/>
-            <a:ext cx="73152" cy="2148840"/>
-          </a:xfrm>
-          <a:prstGeom prst="rect">
-            <a:avLst/>
-          </a:prstGeom>
-          <a:solidFill>
-            <a:srgbClr val="E6B14D"/>
-          </a:solidFill>
-          <a:ln>
-            <a:noFill/>
-          </a:ln>
-        </p:spPr>
-        <p:style>
-          <a:lnRef idx="1">
-            <a:schemeClr val="accent1"/>
-          </a:lnRef>
-          <a:fillRef idx="3">
-            <a:schemeClr val="accent1"/>
-          </a:fillRef>
-          <a:effectRef idx="2">
-            <a:schemeClr val="accent1"/>
-          </a:effectRef>
-          <a:fontRef idx="minor">
-            <a:schemeClr val="lt1"/>
-          </a:fontRef>
-        </p:style>
-        <p:txBody>
-          <a:bodyPr rtlCol="0" anchor="ctr"/>
-          <a:lstStyle/>
-          <a:p>
-            <a:pPr algn="ctr"/>
-          </a:p>
-        </p:txBody>
-      </p:sp>
-      <p:sp>
-        <p:nvSpPr>
-          <p:cNvPr id="12" name="TextBox 11"/>
-          <p:cNvSpPr txBox="1"/>
-          <p:nvPr/>
-        </p:nvSpPr>
-        <p:spPr>
-          <a:xfrm>
-            <a:off x="6675120" y="2039112"/>
-            <a:ext cx="4389120" cy="320040"/>
-          </a:xfrm>
-          <a:prstGeom prst="rect">
-            <a:avLst/>
-          </a:prstGeom>
-          <a:noFill/>
-        </p:spPr>
-        <p:txBody>
-          <a:bodyPr wrap="none">
-            <a:spAutoFit/>
-          </a:bodyPr>
-          <a:lstStyle/>
-          <a:p>
-            <a:pPr>
-              <a:defRPr sz="1100" b="1">
-                <a:solidFill>
-                  <a:srgbClr val="64748B"/>
-                </a:solidFill>
-              </a:defRPr>
-            </a:pPr>
-            <a:r>
-              <a:t>2024 PBT</a:t>
-            </a:r>
-          </a:p>
-        </p:txBody>
-      </p:sp>
-      <p:sp>
-        <p:nvSpPr>
-          <p:cNvPr id="13" name="TextBox 12"/>
-          <p:cNvSpPr txBox="1"/>
-          <p:nvPr/>
-        </p:nvSpPr>
-        <p:spPr>
-          <a:xfrm>
-            <a:off x="6675120" y="2514600"/>
-            <a:ext cx="4389120" cy="640080"/>
-          </a:xfrm>
-          <a:prstGeom prst="rect">
-            <a:avLst/>
-          </a:prstGeom>
-          <a:noFill/>
-        </p:spPr>
-        <p:txBody>
-          <a:bodyPr wrap="none">
-            <a:spAutoFit/>
-          </a:bodyPr>
-          <a:lstStyle/>
-          <a:p>
-            <a:pPr>
-              <a:defRPr sz="2500" b="1">
-                <a:solidFill>
-                  <a:srgbClr val="E6B14D"/>
-                </a:solidFill>
-              </a:defRPr>
-            </a:pPr>
-            <a:r>
-              <a:t>₦1,266.2bn</a:t>
-            </a:r>
-          </a:p>
-        </p:txBody>
-      </p:sp>
-      <p:sp>
-        <p:nvSpPr>
-          <p:cNvPr id="14" name="Right Arrow 13"/>
-          <p:cNvSpPr/>
-          <p:nvPr/>
-        </p:nvSpPr>
-        <p:spPr>
-          <a:xfrm>
-            <a:off x="5669280" y="2468880"/>
-            <a:ext cx="566928" cy="384048"/>
-          </a:xfrm>
-          <a:prstGeom prst="rightArrow">
-            <a:avLst/>
-          </a:prstGeom>
-          <a:solidFill>
-            <a:srgbClr val="64748B"/>
-          </a:solidFill>
-          <a:ln>
-            <a:noFill/>
-          </a:ln>
-        </p:spPr>
-        <p:style>
-          <a:lnRef idx="1">
-            <a:schemeClr val="accent1"/>
-          </a:lnRef>
-          <a:fillRef idx="3">
-            <a:schemeClr val="accent1"/>
-          </a:fillRef>
-          <a:effectRef idx="2">
-            <a:schemeClr val="accent1"/>
-          </a:effectRef>
-          <a:fontRef idx="minor">
-            <a:schemeClr val="lt1"/>
-          </a:fontRef>
-        </p:style>
-        <p:txBody>
-          <a:bodyPr rtlCol="0" anchor="ctr"/>
-          <a:lstStyle/>
-          <a:p>
-            <a:pPr algn="ctr"/>
-          </a:p>
-        </p:txBody>
-      </p:sp>
-      <p:sp>
-        <p:nvSpPr>
-          <p:cNvPr id="15" name="TextBox 14"/>
-          <p:cNvSpPr txBox="1"/>
-          <p:nvPr/>
-        </p:nvSpPr>
-        <p:spPr>
-          <a:xfrm>
-            <a:off x="914400" y="4617720"/>
-            <a:ext cx="10332720" cy="868680"/>
-          </a:xfrm>
-          <a:prstGeom prst="rect">
-            <a:avLst/>
-          </a:prstGeom>
-          <a:noFill/>
-        </p:spPr>
-        <p:txBody>
-          <a:bodyPr wrap="none">
-            <a:spAutoFit/>
-          </a:bodyPr>
-          <a:lstStyle/>
-          <a:p>
-            <a:pPr algn="ctr">
-              <a:defRPr sz="2100" b="1">
-                <a:solidFill>
-                  <a:srgbClr val="0D2340"/>
-                </a:solidFill>
-              </a:defRPr>
-            </a:pPr>
-            <a:r>
-              <a:t>GTCO's Group Profit Before Tax more than doubled from 2023 to 2024.</a:t>
-            </a:r>
-          </a:p>
-        </p:txBody>
-      </p:sp>
-      <p:sp>
-        <p:nvSpPr>
-          <p:cNvPr id="16" name="Rectangle 15"/>
-          <p:cNvSpPr/>
-          <p:nvPr/>
-        </p:nvSpPr>
-        <p:spPr>
-          <a:xfrm>
-            <a:off x="0" y="6510528"/>
-            <a:ext cx="12191695" cy="36576"/>
-          </a:xfrm>
-          <a:prstGeom prst="rect">
-            <a:avLst/>
-          </a:prstGeom>
-          <a:solidFill>
-            <a:srgbClr val="E6B14D"/>
-          </a:solidFill>
-          <a:ln>
-            <a:noFill/>
-          </a:ln>
-        </p:spPr>
-        <p:style>
-          <a:lnRef idx="1">
-            <a:schemeClr val="accent1"/>
-          </a:lnRef>
-          <a:fillRef idx="3">
-            <a:schemeClr val="accent1"/>
-          </a:fillRef>
-          <a:effectRef idx="2">
-            <a:schemeClr val="accent1"/>
-          </a:effectRef>
-          <a:fontRef idx="minor">
-            <a:schemeClr val="lt1"/>
-          </a:fontRef>
-        </p:style>
-        <p:txBody>
-          <a:bodyPr rtlCol="0" anchor="ctr"/>
-          <a:lstStyle/>
-          <a:p>
-            <a:pPr algn="ctr"/>
-          </a:p>
-        </p:txBody>
-      </p:sp>
-      <p:sp>
-        <p:nvSpPr>
-          <p:cNvPr id="17" name="TextBox 16"/>
+          <p:cNvPr id="6" name="TextBox 5"/>
           <p:cNvSpPr txBox="1"/>
           <p:nvPr/>
         </p:nvSpPr>
@@ -4915,7 +4460,7 @@
               </a:defRPr>
             </a:pPr>
             <a:r>
-              <a:t>Source: GTCO 2024 Annual Report, p. 129</a:t>
+              <a:t>Source: Values shown in ₦bn (rounded)</a:t>
             </a:r>
           </a:p>
         </p:txBody>
@@ -5011,198 +4556,6 @@
               </a:defRPr>
             </a:pPr>
             <a:r>
-              <a:t>Group Profit Before Tax Trend</a:t>
-            </a:r>
-          </a:p>
-        </p:txBody>
-      </p:sp>
-      <p:graphicFrame>
-        <p:nvGraphicFramePr>
-          <p:cNvPr id="4" name="Chart 3"/>
-          <p:cNvGraphicFramePr>
-            <a:graphicFrameLocks noGrp="1"/>
-          </p:cNvGraphicFramePr>
-          <p:nvPr/>
-        </p:nvGraphicFramePr>
-        <p:xfrm>
-          <a:off x="914400" y="1417320"/>
-          <a:ext cx="10424160" cy="4526280"/>
-        </p:xfrm>
-        <a:graphic>
-          <a:graphicData uri="http://schemas.openxmlformats.org/drawingml/2006/chart">
-            <c:chart xmlns:c="http://schemas.openxmlformats.org/drawingml/2006/chart" r:id="rId2"/>
-          </a:graphicData>
-        </a:graphic>
-      </p:graphicFrame>
-      <p:sp>
-        <p:nvSpPr>
-          <p:cNvPr id="5" name="Rectangle 4"/>
-          <p:cNvSpPr/>
-          <p:nvPr/>
-        </p:nvSpPr>
-        <p:spPr>
-          <a:xfrm>
-            <a:off x="0" y="6510528"/>
-            <a:ext cx="12191695" cy="36576"/>
-          </a:xfrm>
-          <a:prstGeom prst="rect">
-            <a:avLst/>
-          </a:prstGeom>
-          <a:solidFill>
-            <a:srgbClr val="E6B14D"/>
-          </a:solidFill>
-          <a:ln>
-            <a:noFill/>
-          </a:ln>
-        </p:spPr>
-        <p:style>
-          <a:lnRef idx="1">
-            <a:schemeClr val="accent1"/>
-          </a:lnRef>
-          <a:fillRef idx="3">
-            <a:schemeClr val="accent1"/>
-          </a:fillRef>
-          <a:effectRef idx="2">
-            <a:schemeClr val="accent1"/>
-          </a:effectRef>
-          <a:fontRef idx="minor">
-            <a:schemeClr val="lt1"/>
-          </a:fontRef>
-        </p:style>
-        <p:txBody>
-          <a:bodyPr rtlCol="0" anchor="ctr"/>
-          <a:lstStyle/>
-          <a:p>
-            <a:pPr algn="ctr"/>
-          </a:p>
-        </p:txBody>
-      </p:sp>
-      <p:sp>
-        <p:nvSpPr>
-          <p:cNvPr id="6" name="TextBox 5"/>
-          <p:cNvSpPr txBox="1"/>
-          <p:nvPr/>
-        </p:nvSpPr>
-        <p:spPr>
-          <a:xfrm>
-            <a:off x="594360" y="6574536"/>
-            <a:ext cx="10972800" cy="201168"/>
-          </a:xfrm>
-          <a:prstGeom prst="rect">
-            <a:avLst/>
-          </a:prstGeom>
-          <a:noFill/>
-        </p:spPr>
-        <p:txBody>
-          <a:bodyPr wrap="none">
-            <a:spAutoFit/>
-          </a:bodyPr>
-          <a:lstStyle/>
-          <a:p>
-            <a:pPr>
-              <a:defRPr sz="850">
-                <a:solidFill>
-                  <a:srgbClr val="64748B"/>
-                </a:solidFill>
-              </a:defRPr>
-            </a:pPr>
-            <a:r>
-              <a:t>Source: Values shown in ₦bn</a:t>
-            </a:r>
-          </a:p>
-        </p:txBody>
-      </p:sp>
-    </p:spTree>
-  </p:cSld>
-  <p:clrMapOvr>
-    <a:masterClrMapping/>
-  </p:clrMapOvr>
-</p:sld>
-</file>
-
-<file path=ppt/slides/slide6.xml><?xml version="1.0" encoding="utf-8"?>
-<p:sld xmlns:a="http://schemas.openxmlformats.org/drawingml/2006/main" xmlns:p="http://schemas.openxmlformats.org/presentationml/2006/main" xmlns:r="http://schemas.openxmlformats.org/officeDocument/2006/relationships">
-  <p:cSld>
-    <p:spTree>
-      <p:nvGrpSpPr>
-        <p:cNvPr id="1" name=""/>
-        <p:cNvGrpSpPr/>
-        <p:nvPr/>
-      </p:nvGrpSpPr>
-      <p:grpSpPr/>
-      <p:sp>
-        <p:nvSpPr>
-          <p:cNvPr id="2" name="Rectangle 1"/>
-          <p:cNvSpPr/>
-          <p:nvPr/>
-        </p:nvSpPr>
-        <p:spPr>
-          <a:xfrm>
-            <a:off x="0" y="0"/>
-            <a:ext cx="12191695" cy="6858000"/>
-          </a:xfrm>
-          <a:prstGeom prst="rect">
-            <a:avLst/>
-          </a:prstGeom>
-          <a:solidFill>
-            <a:srgbClr val="FFFFFF"/>
-          </a:solidFill>
-          <a:ln>
-            <a:noFill/>
-          </a:ln>
-        </p:spPr>
-        <p:style>
-          <a:lnRef idx="1">
-            <a:schemeClr val="accent1"/>
-          </a:lnRef>
-          <a:fillRef idx="3">
-            <a:schemeClr val="accent1"/>
-          </a:fillRef>
-          <a:effectRef idx="2">
-            <a:schemeClr val="accent1"/>
-          </a:effectRef>
-          <a:fontRef idx="minor">
-            <a:schemeClr val="lt1"/>
-          </a:fontRef>
-        </p:style>
-        <p:txBody>
-          <a:bodyPr rtlCol="0" anchor="ctr"/>
-          <a:lstStyle/>
-          <a:p>
-            <a:pPr algn="ctr"/>
-          </a:p>
-        </p:txBody>
-      </p:sp>
-      <p:sp>
-        <p:nvSpPr>
-          <p:cNvPr id="3" name="TextBox 2"/>
-          <p:cNvSpPr txBox="1"/>
-          <p:nvPr/>
-        </p:nvSpPr>
-        <p:spPr>
-          <a:xfrm>
-            <a:off x="594360" y="320040"/>
-            <a:ext cx="10881360" cy="594360"/>
-          </a:xfrm>
-          <a:prstGeom prst="rect">
-            <a:avLst/>
-          </a:prstGeom>
-          <a:noFill/>
-        </p:spPr>
-        <p:txBody>
-          <a:bodyPr wrap="none">
-            <a:spAutoFit/>
-          </a:bodyPr>
-          <a:lstStyle/>
-          <a:p>
-            <a:pPr>
-              <a:defRPr sz="2600" b="1">
-                <a:solidFill>
-                  <a:srgbClr val="0D2340"/>
-                </a:solidFill>
-              </a:defRPr>
-            </a:pPr>
-            <a:r>
               <a:t>Sources</a:t>
             </a:r>
           </a:p>
@@ -5241,7 +4594,22 @@
               </a:defRPr>
             </a:pPr>
             <a:r>
-              <a:t>GTCO 2024 Annual Report, p. 129</a:t>
+              <a:t>GTCO 2023 Annual Report, p. 8</a:t>
+            </a:r>
+          </a:p>
+          <a:p>
+            <a:pPr>
+              <a:spcAft>
+                <a:spcPts val="900"/>
+              </a:spcAft>
+              <a:defRPr sz="1400">
+                <a:solidFill>
+                  <a:srgbClr val="1E293B"/>
+                </a:solidFill>
+              </a:defRPr>
+            </a:pPr>
+            <a:r>
+              <a:t>GTCO 2024 Annual Report, p. 78</a:t>
             </a:r>
           </a:p>
           <a:p>

</xml_diff>